<commit_message>
Fix boom-distance bug, regenerate results, add browser simulator
Co-Authored-By: Claude Sonnet 5.5 <noreply@anthropic.com>
Claude-Session: https://claude.ai/code/session_019CCyrHAsBaRqwAZKT8YM2R
</commit_message>
<xml_diff>
--- a/deck/MARLIN_Hybrid_Proposal.pptx
+++ b/deck/MARLIN_Hybrid_Proposal.pptx
@@ -116,28 +116,28 @@
   <p:extLst>
     <p:ext uri="{521415D9-36F7-43E2-AB2F-B90AF26B5E84}">
       <p14:sectionLst xmlns:p14="http://schemas.microsoft.com/office/powerpoint/2010/main">
-        <p14:section name="Overview" id="{46246ec5-047c-901f-3749-90ced810bbd8}">
+        <p14:section name="Overview" id="{efc3e620-6942-19b1-a7e1-daaed51f568b}">
           <p14:sldIdLst>
             <p14:sldId id="256"/>
             <p14:sldId id="257"/>
             <p14:sldId id="258"/>
           </p14:sldIdLst>
         </p14:section>
-        <p14:section name="Solution" id="{8b375aa4-db4b-e38d-124e-16afc194470c}">
+        <p14:section name="Solution" id="{acfd011c-cc10-613d-c294-0c27ec25d32f}">
           <p14:sldIdLst>
             <p14:sldId id="259"/>
             <p14:sldId id="260"/>
             <p14:sldId id="261"/>
           </p14:sldIdLst>
         </p14:section>
-        <p14:section name="Delivery" id="{9ca14cb8-bb59-df1e-526e-341743c8d5d6}">
+        <p14:section name="Delivery" id="{06fb358c-4475-93d8-57b2-8a1573ea3eb1}">
           <p14:sldIdLst>
             <p14:sldId id="262"/>
             <p14:sldId id="263"/>
             <p14:sldId id="264"/>
           </p14:sldIdLst>
         </p14:section>
-        <p14:section name="Close" id="{50910347-0d4e-ba30-64f5-fd42d849b3bb}">
+        <p14:section name="Close" id="{b568e2e0-a39c-f1e3-0e4d-f5a4bbc98849}">
           <p14:sldIdLst>
             <p14:sldId id="265"/>
           </p14:sldIdLst>
@@ -1338,7 +1338,7 @@
           <a:p>
             <a:r>
               <a:rPr lang="en-US" dirty="0"/>
-              <a:t>Cost and test plan (20 s): Everything is standard marine hardware, and the software keeps air off unless jellyfish are arriving. We do not quote prices without supplier data. Gate one is a bench flume plus a controller simulation we can show at Demo Days. Our v5 screening simulation compares strategies under uncalibrated assumptions: roughly 50 to 65 percent less mass reaching the intake in calm seas and about 12 percent in a 2 metre storm. Those are not field claims; the flume will measure the real values.</a:t>
+              <a:t>Cost and test plan (20 s): Everything is standard marine hardware, and the software keeps air off unless jellyfish are arriving. We do not quote prices without supplier data. Gate one is a bench flume plus a controller simulation we can show at Demo Days. Our v5 screening simulation compares strategies under uncalibrated assumptions: roughly 45 to 65 percent less mass reaching the intake in calm seas and about 11 percent in a 2 metre storm. Those are not field claims; the flume will measure the real values.</a:t>
             </a:r>
             <a:endParaRPr lang="en-US" dirty="0"/>
           </a:p>
@@ -12616,7 +12616,7 @@
                   <a:schemeClr val="bg1"/>
                 </a:solidFill>
               </a:rPr>
-              <a:t>A clear cut in bloom mass reaching the intake versus no response (our screening model suggests roughly 50-65% in calm seas and about 12% in a 2 m storm, so flume tests must measure the real figure); the controller re-aims and stops correctly; bycatch, pressure change, kWh per tonne and staff-hours recorded.</a:t>
+              <a:t>A clear cut in bloom mass reaching the intake versus no response (our screening model suggests roughly 45-65% in calm seas and about 11% in a 2 m storm, so flume tests must measure the real figure); the controller re-aims and stops correctly; bycatch, pressure change, kWh per tonne and staff-hours recorded.</a:t>
             </a:r>
             <a:endParaRPr lang="en-US" sz="1500" dirty="0"/>
           </a:p>

</xml_diff>